<commit_message>
Correct risk-driver ranking: load growth (r=0.55) narrowly tops age (r=0.52)
</commit_message>
<xml_diff>
--- a/presentation/NGES_Board_Presentation.pptx
+++ b/presentation/NGES_Board_Presentation.pptx
@@ -7705,7 +7705,7 @@
                 </a:solidFill>
                 <a:latin typeface="Segoe UI"/>
               </a:rPr>
-              <a:t>Age is the strongest factor, then utilization, then outage history. Several critical assets also face double-digit projected load growth.</a:t>
+              <a:t>Projected load growth (r = 0.55) and age (r = 0.52) are the top two drivers, essentially tied, followed by utilization and outage history - the risk score looks forward, not just backward.</a:t>
             </a:r>
           </a:p>
           <a:p>
@@ -7759,7 +7759,7 @@
         <p:spPr>
           <a:xfrm>
             <a:off x="6035040" y="1920240"/>
-            <a:ext cx="5577840" cy="3524589"/>
+            <a:ext cx="5577840" cy="3687215"/>
           </a:xfrm>
           <a:prstGeom prst="rect">
             <a:avLst/>

</xml_diff>